<commit_message>
Harden companion presentation generation
</commit_message>
<xml_diff>
--- a/Studies/The-Ontology-of-Coexistence/Coexistence-in-Comparison-MD-vs-Advaita-Philosophy-Science.pptx
+++ b/Studies/The-Ontology-of-Coexistence/Coexistence-in-Comparison-MD-vs-Advaita-Philosophy-Science.pptx
@@ -2,128 +2,33 @@
 <file path=ppt/presentation.xml><?xml version="1.0" encoding="utf-8"?>
 <p:presentation xmlns:p="http://schemas.openxmlformats.org/presentationml/2006/main">
   <p:sldMasterIdLst>
-    <p:sldMasterId xmlns:r="http://schemas.openxmlformats.org/officeDocument/2006/relationships" id="2147483648" r:id="R8aa192d6767647f9"/>
+    <p:sldMasterId xmlns:r="http://schemas.openxmlformats.org/officeDocument/2006/relationships" id="2147483648" r:id="R9d74b22827644129"/>
   </p:sldMasterIdLst>
   <p:notesMasterIdLst>
-    <p:notesMasterId xmlns:r="http://schemas.openxmlformats.org/officeDocument/2006/relationships" r:id="Rb4341bb645f7433e"/>
+    <p:notesMasterId xmlns:r="http://schemas.openxmlformats.org/officeDocument/2006/relationships" r:id="Rc8c9cee1073b4297"/>
   </p:notesMasterIdLst>
   <p:sldIdLst>
-    <p:sldId xmlns:r="http://schemas.openxmlformats.org/officeDocument/2006/relationships" id="256" r:id="Rd248599913654893"/>
-    <p:sldId xmlns:r="http://schemas.openxmlformats.org/officeDocument/2006/relationships" id="257" r:id="R08550a15d9c747f7"/>
-    <p:sldId xmlns:r="http://schemas.openxmlformats.org/officeDocument/2006/relationships" id="258" r:id="Rdb914a694ee14a1a"/>
-    <p:sldId xmlns:r="http://schemas.openxmlformats.org/officeDocument/2006/relationships" id="259" r:id="Re6885e39753641b6"/>
-    <p:sldId xmlns:r="http://schemas.openxmlformats.org/officeDocument/2006/relationships" id="260" r:id="R10f3b66ea3e54e18"/>
-    <p:sldId xmlns:r="http://schemas.openxmlformats.org/officeDocument/2006/relationships" id="261" r:id="R0c4ad2eed2b74b8b"/>
-    <p:sldId xmlns:r="http://schemas.openxmlformats.org/officeDocument/2006/relationships" id="262" r:id="R54de75f1ffed4157"/>
-    <p:sldId xmlns:r="http://schemas.openxmlformats.org/officeDocument/2006/relationships" id="263" r:id="R02a0e6f6e4664a49"/>
-    <p:sldId xmlns:r="http://schemas.openxmlformats.org/officeDocument/2006/relationships" id="264" r:id="R965215b63ca84630"/>
-    <p:sldId xmlns:r="http://schemas.openxmlformats.org/officeDocument/2006/relationships" id="265" r:id="Rfbb586be29e64bc7"/>
-    <p:sldId xmlns:r="http://schemas.openxmlformats.org/officeDocument/2006/relationships" id="266" r:id="Rb44394de6eeb4c88"/>
-    <p:sldId xmlns:r="http://schemas.openxmlformats.org/officeDocument/2006/relationships" id="267" r:id="Rb2e8ef7b4c814f30"/>
-    <p:sldId xmlns:r="http://schemas.openxmlformats.org/officeDocument/2006/relationships" id="268" r:id="R80614fa788604d43"/>
-    <p:sldId xmlns:r="http://schemas.openxmlformats.org/officeDocument/2006/relationships" id="269" r:id="Rf03ca450f683412d"/>
-    <p:sldId xmlns:r="http://schemas.openxmlformats.org/officeDocument/2006/relationships" id="270" r:id="R345ffbb5d36f481c"/>
-    <p:sldId xmlns:r="http://schemas.openxmlformats.org/officeDocument/2006/relationships" id="271" r:id="R867bd1da647d4aa2"/>
-    <p:sldId xmlns:r="http://schemas.openxmlformats.org/officeDocument/2006/relationships" id="272" r:id="R8e9e5d2a8a214f5a"/>
-    <p:sldId xmlns:r="http://schemas.openxmlformats.org/officeDocument/2006/relationships" id="273" r:id="Rcc93124099f24238"/>
+    <p:sldId xmlns:r="http://schemas.openxmlformats.org/officeDocument/2006/relationships" id="256" r:id="R92aa9f857380473e"/>
+    <p:sldId xmlns:r="http://schemas.openxmlformats.org/officeDocument/2006/relationships" id="257" r:id="Rf7c5f76cf5a14211"/>
+    <p:sldId xmlns:r="http://schemas.openxmlformats.org/officeDocument/2006/relationships" id="258" r:id="R52a69491f71f4f37"/>
+    <p:sldId xmlns:r="http://schemas.openxmlformats.org/officeDocument/2006/relationships" id="259" r:id="R342775ee7ca44951"/>
+    <p:sldId xmlns:r="http://schemas.openxmlformats.org/officeDocument/2006/relationships" id="260" r:id="R9aa42f6e6a41438a"/>
+    <p:sldId xmlns:r="http://schemas.openxmlformats.org/officeDocument/2006/relationships" id="261" r:id="Ra905540d0b404d10"/>
+    <p:sldId xmlns:r="http://schemas.openxmlformats.org/officeDocument/2006/relationships" id="262" r:id="Raeaea35503114ad5"/>
+    <p:sldId xmlns:r="http://schemas.openxmlformats.org/officeDocument/2006/relationships" id="263" r:id="Rf3470618da3e4878"/>
+    <p:sldId xmlns:r="http://schemas.openxmlformats.org/officeDocument/2006/relationships" id="264" r:id="Rc29e4432b3654346"/>
+    <p:sldId xmlns:r="http://schemas.openxmlformats.org/officeDocument/2006/relationships" id="265" r:id="R5a10bd9939994467"/>
+    <p:sldId xmlns:r="http://schemas.openxmlformats.org/officeDocument/2006/relationships" id="266" r:id="R0eb661fb203a45df"/>
+    <p:sldId xmlns:r="http://schemas.openxmlformats.org/officeDocument/2006/relationships" id="267" r:id="Rb1c53e70f93f4e00"/>
+    <p:sldId xmlns:r="http://schemas.openxmlformats.org/officeDocument/2006/relationships" id="268" r:id="R84e5390e6c634808"/>
+    <p:sldId xmlns:r="http://schemas.openxmlformats.org/officeDocument/2006/relationships" id="269" r:id="R686ba1bc923448e4"/>
+    <p:sldId xmlns:r="http://schemas.openxmlformats.org/officeDocument/2006/relationships" id="270" r:id="R48c4111260694b37"/>
+    <p:sldId xmlns:r="http://schemas.openxmlformats.org/officeDocument/2006/relationships" id="271" r:id="R5b9c96dbeb1541f3"/>
+    <p:sldId xmlns:r="http://schemas.openxmlformats.org/officeDocument/2006/relationships" id="272" r:id="R98ec1cbfde524283"/>
+    <p:sldId xmlns:r="http://schemas.openxmlformats.org/officeDocument/2006/relationships" id="273" r:id="Re14410c675ed42e0"/>
   </p:sldIdLst>
   <p:sldSz cx="9144000" cy="5143500"/>
   <p:notesSz cx="6858000" cy="9144000"/>
-  <p:defaultTextStyle>
-    <a:defPPr xmlns:a="http://schemas.openxmlformats.org/drawingml/2006/main">
-      <a:defRPr lang="en-US"/>
-    </a:defPPr>
-    <a:lvl1pPr xmlns:a="http://schemas.openxmlformats.org/drawingml/2006/main" marL="0" indent="0" algn="l" defTabSz="914400">
-      <a:defRPr sz="1800" kern="1200">
-        <a:solidFill>
-          <a:schemeClr val="tx1"/>
-        </a:solidFill>
-        <a:latin typeface="+mn-lt"/>
-        <a:ea typeface="+mn-ea"/>
-        <a:cs typeface="+mn-cs"/>
-      </a:defRPr>
-    </a:lvl1pPr>
-    <a:lvl2pPr xmlns:a="http://schemas.openxmlformats.org/drawingml/2006/main" marL="457200" indent="0" algn="l" defTabSz="914400">
-      <a:defRPr sz="1800" kern="1200">
-        <a:solidFill>
-          <a:schemeClr val="tx1"/>
-        </a:solidFill>
-        <a:latin typeface="+mn-lt"/>
-        <a:ea typeface="+mn-ea"/>
-        <a:cs typeface="+mn-cs"/>
-      </a:defRPr>
-    </a:lvl2pPr>
-    <a:lvl3pPr xmlns:a="http://schemas.openxmlformats.org/drawingml/2006/main" marL="914400" indent="0" algn="l" defTabSz="914400">
-      <a:defRPr sz="1800" kern="1200">
-        <a:solidFill>
-          <a:schemeClr val="tx1"/>
-        </a:solidFill>
-        <a:latin typeface="+mn-lt"/>
-        <a:ea typeface="+mn-ea"/>
-        <a:cs typeface="+mn-cs"/>
-      </a:defRPr>
-    </a:lvl3pPr>
-    <a:lvl4pPr xmlns:a="http://schemas.openxmlformats.org/drawingml/2006/main" marL="1371600" indent="0" algn="l" defTabSz="914400">
-      <a:defRPr sz="1800" kern="1200">
-        <a:solidFill>
-          <a:schemeClr val="tx1"/>
-        </a:solidFill>
-        <a:latin typeface="+mn-lt"/>
-        <a:ea typeface="+mn-ea"/>
-        <a:cs typeface="+mn-cs"/>
-      </a:defRPr>
-    </a:lvl4pPr>
-    <a:lvl5pPr xmlns:a="http://schemas.openxmlformats.org/drawingml/2006/main" marL="1828800" indent="0" algn="l" defTabSz="914400">
-      <a:defRPr sz="1800" kern="1200">
-        <a:solidFill>
-          <a:schemeClr val="tx1"/>
-        </a:solidFill>
-        <a:latin typeface="+mn-lt"/>
-        <a:ea typeface="+mn-ea"/>
-        <a:cs typeface="+mn-cs"/>
-      </a:defRPr>
-    </a:lvl5pPr>
-    <a:lvl6pPr xmlns:a="http://schemas.openxmlformats.org/drawingml/2006/main" marL="2286000" indent="0" algn="l" defTabSz="914400">
-      <a:defRPr sz="1800" kern="1200">
-        <a:solidFill>
-          <a:schemeClr val="tx1"/>
-        </a:solidFill>
-        <a:latin typeface="+mn-lt"/>
-        <a:ea typeface="+mn-ea"/>
-        <a:cs typeface="+mn-cs"/>
-      </a:defRPr>
-    </a:lvl6pPr>
-    <a:lvl7pPr xmlns:a="http://schemas.openxmlformats.org/drawingml/2006/main" marL="2743200" indent="0" algn="l" defTabSz="914400">
-      <a:defRPr sz="1800" kern="1200">
-        <a:solidFill>
-          <a:schemeClr val="tx1"/>
-        </a:solidFill>
-        <a:latin typeface="+mn-lt"/>
-        <a:ea typeface="+mn-ea"/>
-        <a:cs typeface="+mn-cs"/>
-      </a:defRPr>
-    </a:lvl7pPr>
-    <a:lvl8pPr xmlns:a="http://schemas.openxmlformats.org/drawingml/2006/main" marL="3200400" indent="0" algn="l" defTabSz="914400">
-      <a:defRPr sz="1800" kern="1200">
-        <a:solidFill>
-          <a:schemeClr val="tx1"/>
-        </a:solidFill>
-        <a:latin typeface="+mn-lt"/>
-        <a:ea typeface="+mn-ea"/>
-        <a:cs typeface="+mn-cs"/>
-      </a:defRPr>
-    </a:lvl8pPr>
-    <a:lvl9pPr xmlns:a="http://schemas.openxmlformats.org/drawingml/2006/main" marL="3657600" indent="0" algn="l" defTabSz="914400">
-      <a:defRPr sz="1800" kern="1200">
-        <a:solidFill>
-          <a:schemeClr val="tx1"/>
-        </a:solidFill>
-        <a:latin typeface="+mn-lt"/>
-        <a:ea typeface="+mn-ea"/>
-        <a:cs typeface="+mn-cs"/>
-      </a:defRPr>
-    </a:lvl9pPr>
-  </p:defaultTextStyle>
 </p:presentation>
 </file>
 
@@ -1999,7 +1904,7 @@
   </p:cSld>
   <p:clrMap bg1="lt1" tx1="dk1" bg2="dk2" tx2="lt2" accent1="accent1" accent2="accent2" accent3="accent3" accent4="accent4" accent5="accent5" accent6="accent6" hlink="hlink" folHlink="folHlink"/>
   <p:sldLayoutIdLst>
-    <p:sldLayoutId xmlns:r="http://schemas.openxmlformats.org/officeDocument/2006/relationships" id="2147483649" r:id="Re48c6f1c50264849"/>
+    <p:sldLayoutId xmlns:r="http://schemas.openxmlformats.org/officeDocument/2006/relationships" id="2147483649" r:id="Rae7ebbb89c6d42b7"/>
   </p:sldLayoutIdLst>
   <p:hf sldNum="0" hdr="0" ftr="0" dt="0"/>
   <p:txStyles>
@@ -3554,7 +3459,7 @@
         </p:nvSpPr>
         <p:spPr>
           <a:xfrm xmlns:a="http://schemas.openxmlformats.org/drawingml/2006/main">
-            <a:off x="640080" y="2880360"/>
+            <a:off x="640080" y="3063240"/>
             <a:ext cx="5120640" cy="365760"/>
           </a:xfrm>
           <a:prstGeom xmlns:a="http://schemas.openxmlformats.org/drawingml/2006/main" prst="rect">

</xml_diff>

<commit_message>
Improve ontology teaching order and consolidate editorial notes
</commit_message>
<xml_diff>
--- a/Studies/The-Ontology-of-Coexistence/Coexistence-in-Comparison-MD-vs-Advaita-Philosophy-Science.pptx
+++ b/Studies/The-Ontology-of-Coexistence/Coexistence-in-Comparison-MD-vs-Advaita-Philosophy-Science.pptx
@@ -2,30 +2,30 @@
 <file path=ppt/presentation.xml><?xml version="1.0" encoding="utf-8"?>
 <p:presentation xmlns:p="http://schemas.openxmlformats.org/presentationml/2006/main">
   <p:sldMasterIdLst>
-    <p:sldMasterId xmlns:r="http://schemas.openxmlformats.org/officeDocument/2006/relationships" id="2147483648" r:id="Rf899048f37054672"/>
+    <p:sldMasterId xmlns:r="http://schemas.openxmlformats.org/officeDocument/2006/relationships" id="2147483648" r:id="Rce68a6eebf654dc3"/>
   </p:sldMasterIdLst>
   <p:notesMasterIdLst>
-    <p:notesMasterId xmlns:r="http://schemas.openxmlformats.org/officeDocument/2006/relationships" r:id="Rd7e3b6d09d6249d9"/>
+    <p:notesMasterId xmlns:r="http://schemas.openxmlformats.org/officeDocument/2006/relationships" r:id="Ra56f6017fcbe47ca"/>
   </p:notesMasterIdLst>
   <p:sldIdLst>
-    <p:sldId xmlns:r="http://schemas.openxmlformats.org/officeDocument/2006/relationships" id="256" r:id="Rf3de317f2b364a0c"/>
-    <p:sldId xmlns:r="http://schemas.openxmlformats.org/officeDocument/2006/relationships" id="257" r:id="R6e5406574ed64386"/>
-    <p:sldId xmlns:r="http://schemas.openxmlformats.org/officeDocument/2006/relationships" id="258" r:id="R82f5af8e5a7d4c42"/>
-    <p:sldId xmlns:r="http://schemas.openxmlformats.org/officeDocument/2006/relationships" id="259" r:id="Rad046b7ed0c64ad8"/>
-    <p:sldId xmlns:r="http://schemas.openxmlformats.org/officeDocument/2006/relationships" id="260" r:id="Rd4ebb6048202494f"/>
-    <p:sldId xmlns:r="http://schemas.openxmlformats.org/officeDocument/2006/relationships" id="261" r:id="R43f4b4ce31894369"/>
-    <p:sldId xmlns:r="http://schemas.openxmlformats.org/officeDocument/2006/relationships" id="262" r:id="R313d09cbca0640bf"/>
-    <p:sldId xmlns:r="http://schemas.openxmlformats.org/officeDocument/2006/relationships" id="263" r:id="Rfb24fbe7584b4ace"/>
-    <p:sldId xmlns:r="http://schemas.openxmlformats.org/officeDocument/2006/relationships" id="264" r:id="Rb4d4f488f204476d"/>
-    <p:sldId xmlns:r="http://schemas.openxmlformats.org/officeDocument/2006/relationships" id="265" r:id="R00eb9da0f2384528"/>
-    <p:sldId xmlns:r="http://schemas.openxmlformats.org/officeDocument/2006/relationships" id="266" r:id="R9183bd6ad14142d8"/>
-    <p:sldId xmlns:r="http://schemas.openxmlformats.org/officeDocument/2006/relationships" id="267" r:id="R9327ffa5fe7c491e"/>
-    <p:sldId xmlns:r="http://schemas.openxmlformats.org/officeDocument/2006/relationships" id="268" r:id="R964cec0555fe44b2"/>
-    <p:sldId xmlns:r="http://schemas.openxmlformats.org/officeDocument/2006/relationships" id="269" r:id="Raba2fe1d196740e6"/>
-    <p:sldId xmlns:r="http://schemas.openxmlformats.org/officeDocument/2006/relationships" id="270" r:id="Rfa656926efe74e58"/>
-    <p:sldId xmlns:r="http://schemas.openxmlformats.org/officeDocument/2006/relationships" id="271" r:id="Ra4a2a2fd64ac4970"/>
-    <p:sldId xmlns:r="http://schemas.openxmlformats.org/officeDocument/2006/relationships" id="272" r:id="Rc364e0daccd24308"/>
-    <p:sldId xmlns:r="http://schemas.openxmlformats.org/officeDocument/2006/relationships" id="273" r:id="Rfb624bd7c22943b1"/>
+    <p:sldId xmlns:r="http://schemas.openxmlformats.org/officeDocument/2006/relationships" id="256" r:id="Rf6c28b3d635a459a"/>
+    <p:sldId xmlns:r="http://schemas.openxmlformats.org/officeDocument/2006/relationships" id="257" r:id="Re9771d5632c5405b"/>
+    <p:sldId xmlns:r="http://schemas.openxmlformats.org/officeDocument/2006/relationships" id="258" r:id="R721530ec9b18407f"/>
+    <p:sldId xmlns:r="http://schemas.openxmlformats.org/officeDocument/2006/relationships" id="259" r:id="R786a7f3ad13045ae"/>
+    <p:sldId xmlns:r="http://schemas.openxmlformats.org/officeDocument/2006/relationships" id="260" r:id="R52a279c784d74201"/>
+    <p:sldId xmlns:r="http://schemas.openxmlformats.org/officeDocument/2006/relationships" id="261" r:id="Rac1f794562d24520"/>
+    <p:sldId xmlns:r="http://schemas.openxmlformats.org/officeDocument/2006/relationships" id="262" r:id="R645604d6dceb4b40"/>
+    <p:sldId xmlns:r="http://schemas.openxmlformats.org/officeDocument/2006/relationships" id="263" r:id="Ref6e4ca490f64365"/>
+    <p:sldId xmlns:r="http://schemas.openxmlformats.org/officeDocument/2006/relationships" id="264" r:id="R09423f2c17654fc5"/>
+    <p:sldId xmlns:r="http://schemas.openxmlformats.org/officeDocument/2006/relationships" id="265" r:id="Ra650b7f2f741487f"/>
+    <p:sldId xmlns:r="http://schemas.openxmlformats.org/officeDocument/2006/relationships" id="266" r:id="R2e793bd365d9469c"/>
+    <p:sldId xmlns:r="http://schemas.openxmlformats.org/officeDocument/2006/relationships" id="267" r:id="Rc52360c1359e49d1"/>
+    <p:sldId xmlns:r="http://schemas.openxmlformats.org/officeDocument/2006/relationships" id="268" r:id="R7afef29c0d8a4708"/>
+    <p:sldId xmlns:r="http://schemas.openxmlformats.org/officeDocument/2006/relationships" id="269" r:id="Rb5f9130201b043b4"/>
+    <p:sldId xmlns:r="http://schemas.openxmlformats.org/officeDocument/2006/relationships" id="270" r:id="R7e6abf1fc53b406f"/>
+    <p:sldId xmlns:r="http://schemas.openxmlformats.org/officeDocument/2006/relationships" id="271" r:id="Ra6b857e7e7fa4349"/>
+    <p:sldId xmlns:r="http://schemas.openxmlformats.org/officeDocument/2006/relationships" id="272" r:id="R1309cb03516d48a9"/>
+    <p:sldId xmlns:r="http://schemas.openxmlformats.org/officeDocument/2006/relationships" id="273" r:id="R82ee14d7010245d9"/>
   </p:sldIdLst>
   <p:sldSz cx="9144000" cy="5143500"/>
   <p:notesSz cx="6858000" cy="9144000"/>
@@ -1988,7 +1988,7 @@
   </p:cSld>
   <p:clrMap bg1="lt1" tx1="dk1" bg2="dk2" tx2="lt2" accent1="accent1" accent2="accent2" accent3="accent3" accent4="accent4" accent5="accent5" accent6="accent6" hlink="hlink" folHlink="folHlink"/>
   <p:sldLayoutIdLst>
-    <p:sldLayoutId xmlns:r="http://schemas.openxmlformats.org/officeDocument/2006/relationships" id="2147483649" r:id="R553d3bfc828d4e08"/>
+    <p:sldLayoutId xmlns:r="http://schemas.openxmlformats.org/officeDocument/2006/relationships" id="2147483649" r:id="R3140d1553a5344dc"/>
   </p:sldLayoutIdLst>
   <p:hf sldNum="0" hdr="0" ftr="0" dt="0"/>
   <p:txStyles>
@@ -10717,7 +10717,29 @@
                 <a:ea typeface="Calibri"/>
                 <a:cs typeface="Calibri"/>
               </a:rPr>
-              <a:t>CU 6.2.1  ·  TU 2.1.1  ·  DDV vv. 1–5  ·  VC v. 217  ·  MVD §§1.8, 1.13  ·  study §5.6</a:t>
+              <a:t>CU 6.2.1  ·  TU 2.1.1  ·  DDV vv. 1–5  ·  VC v. 217  ·  </a:t>
+            </a:r>
+            <a:r>
+              <a:rPr sz="950" b="0" i="1" u="none" cap="none">
+                <a:solidFill>
+                  <a:srgbClr val="5A6377"/>
+                </a:solidFill>
+                <a:latin typeface="Calibri"/>
+                <a:ea typeface="Calibri"/>
+                <a:cs typeface="Calibri"/>
+              </a:rPr>
+              <a:t>Study §§1.9, 1.14</a:t>
+            </a:r>
+            <a:r>
+              <a:rPr sz="950" b="0" i="1" u="none" cap="none">
+                <a:solidFill>
+                  <a:srgbClr val="5A6377"/>
+                </a:solidFill>
+                <a:latin typeface="Calibri"/>
+                <a:ea typeface="Calibri"/>
+                <a:cs typeface="Calibri"/>
+              </a:rPr>
+              <a:t>  ·  study §5.6</a:t>
             </a:r>
           </a:p>
         </p:txBody>

</xml_diff>

<commit_message>
Harmonize ontology presentations with the revised study
</commit_message>
<xml_diff>
--- a/Studies/The-Ontology-of-Coexistence/Coexistence-in-Comparison-MD-vs-Advaita-Philosophy-Science.pptx
+++ b/Studies/The-Ontology-of-Coexistence/Coexistence-in-Comparison-MD-vs-Advaita-Philosophy-Science.pptx
@@ -2,30 +2,30 @@
 <file path=ppt/presentation.xml><?xml version="1.0" encoding="utf-8"?>
 <p:presentation xmlns:p="http://schemas.openxmlformats.org/presentationml/2006/main">
   <p:sldMasterIdLst>
-    <p:sldMasterId xmlns:r="http://schemas.openxmlformats.org/officeDocument/2006/relationships" id="2147483648" r:id="Rce68a6eebf654dc3"/>
+    <p:sldMasterId xmlns:r="http://schemas.openxmlformats.org/officeDocument/2006/relationships" id="2147483648" r:id="Rc7ee847b1e474d4f"/>
   </p:sldMasterIdLst>
   <p:notesMasterIdLst>
-    <p:notesMasterId xmlns:r="http://schemas.openxmlformats.org/officeDocument/2006/relationships" r:id="Ra56f6017fcbe47ca"/>
+    <p:notesMasterId xmlns:r="http://schemas.openxmlformats.org/officeDocument/2006/relationships" r:id="R5897c84b1fd54ffd"/>
   </p:notesMasterIdLst>
   <p:sldIdLst>
-    <p:sldId xmlns:r="http://schemas.openxmlformats.org/officeDocument/2006/relationships" id="256" r:id="Rf6c28b3d635a459a"/>
-    <p:sldId xmlns:r="http://schemas.openxmlformats.org/officeDocument/2006/relationships" id="257" r:id="Re9771d5632c5405b"/>
-    <p:sldId xmlns:r="http://schemas.openxmlformats.org/officeDocument/2006/relationships" id="258" r:id="R721530ec9b18407f"/>
-    <p:sldId xmlns:r="http://schemas.openxmlformats.org/officeDocument/2006/relationships" id="259" r:id="R786a7f3ad13045ae"/>
-    <p:sldId xmlns:r="http://schemas.openxmlformats.org/officeDocument/2006/relationships" id="260" r:id="R52a279c784d74201"/>
-    <p:sldId xmlns:r="http://schemas.openxmlformats.org/officeDocument/2006/relationships" id="261" r:id="Rac1f794562d24520"/>
-    <p:sldId xmlns:r="http://schemas.openxmlformats.org/officeDocument/2006/relationships" id="262" r:id="R645604d6dceb4b40"/>
-    <p:sldId xmlns:r="http://schemas.openxmlformats.org/officeDocument/2006/relationships" id="263" r:id="Ref6e4ca490f64365"/>
-    <p:sldId xmlns:r="http://schemas.openxmlformats.org/officeDocument/2006/relationships" id="264" r:id="R09423f2c17654fc5"/>
-    <p:sldId xmlns:r="http://schemas.openxmlformats.org/officeDocument/2006/relationships" id="265" r:id="Ra650b7f2f741487f"/>
-    <p:sldId xmlns:r="http://schemas.openxmlformats.org/officeDocument/2006/relationships" id="266" r:id="R2e793bd365d9469c"/>
-    <p:sldId xmlns:r="http://schemas.openxmlformats.org/officeDocument/2006/relationships" id="267" r:id="Rc52360c1359e49d1"/>
-    <p:sldId xmlns:r="http://schemas.openxmlformats.org/officeDocument/2006/relationships" id="268" r:id="R7afef29c0d8a4708"/>
-    <p:sldId xmlns:r="http://schemas.openxmlformats.org/officeDocument/2006/relationships" id="269" r:id="Rb5f9130201b043b4"/>
-    <p:sldId xmlns:r="http://schemas.openxmlformats.org/officeDocument/2006/relationships" id="270" r:id="R7e6abf1fc53b406f"/>
-    <p:sldId xmlns:r="http://schemas.openxmlformats.org/officeDocument/2006/relationships" id="271" r:id="Ra6b857e7e7fa4349"/>
-    <p:sldId xmlns:r="http://schemas.openxmlformats.org/officeDocument/2006/relationships" id="272" r:id="R1309cb03516d48a9"/>
-    <p:sldId xmlns:r="http://schemas.openxmlformats.org/officeDocument/2006/relationships" id="273" r:id="R82ee14d7010245d9"/>
+    <p:sldId xmlns:r="http://schemas.openxmlformats.org/officeDocument/2006/relationships" id="256" r:id="Rdc507d658f4b449e"/>
+    <p:sldId xmlns:r="http://schemas.openxmlformats.org/officeDocument/2006/relationships" id="257" r:id="Reb0e7a9cf82743a1"/>
+    <p:sldId xmlns:r="http://schemas.openxmlformats.org/officeDocument/2006/relationships" id="258" r:id="Ree88f61ce30545ea"/>
+    <p:sldId xmlns:r="http://schemas.openxmlformats.org/officeDocument/2006/relationships" id="259" r:id="R5b07acc491994275"/>
+    <p:sldId xmlns:r="http://schemas.openxmlformats.org/officeDocument/2006/relationships" id="260" r:id="Re48ded498c4e457e"/>
+    <p:sldId xmlns:r="http://schemas.openxmlformats.org/officeDocument/2006/relationships" id="261" r:id="R5fe1f94cd3344581"/>
+    <p:sldId xmlns:r="http://schemas.openxmlformats.org/officeDocument/2006/relationships" id="262" r:id="Rc0416133ae11430e"/>
+    <p:sldId xmlns:r="http://schemas.openxmlformats.org/officeDocument/2006/relationships" id="263" r:id="Rc22b61ce53de4b08"/>
+    <p:sldId xmlns:r="http://schemas.openxmlformats.org/officeDocument/2006/relationships" id="264" r:id="R0de0883bcf634d55"/>
+    <p:sldId xmlns:r="http://schemas.openxmlformats.org/officeDocument/2006/relationships" id="265" r:id="Rb1f8fef939304cac"/>
+    <p:sldId xmlns:r="http://schemas.openxmlformats.org/officeDocument/2006/relationships" id="266" r:id="R580d0017e77a4111"/>
+    <p:sldId xmlns:r="http://schemas.openxmlformats.org/officeDocument/2006/relationships" id="267" r:id="R6a12b88d96a749ed"/>
+    <p:sldId xmlns:r="http://schemas.openxmlformats.org/officeDocument/2006/relationships" id="268" r:id="Rc7d9dde61ce64160"/>
+    <p:sldId xmlns:r="http://schemas.openxmlformats.org/officeDocument/2006/relationships" id="269" r:id="R831ffedd3cd647f3"/>
+    <p:sldId xmlns:r="http://schemas.openxmlformats.org/officeDocument/2006/relationships" id="270" r:id="R9ca6398018b646a9"/>
+    <p:sldId xmlns:r="http://schemas.openxmlformats.org/officeDocument/2006/relationships" id="271" r:id="R0a1f6d2506664fd0"/>
+    <p:sldId xmlns:r="http://schemas.openxmlformats.org/officeDocument/2006/relationships" id="272" r:id="R18505049fc7944b9"/>
+    <p:sldId xmlns:r="http://schemas.openxmlformats.org/officeDocument/2006/relationships" id="273" r:id="R2da5b987f0044e60"/>
   </p:sldIdLst>
   <p:sldSz cx="9144000" cy="5143500"/>
   <p:notesSz cx="6858000" cy="9144000"/>
@@ -491,7 +491,7 @@
               <a:buNone/>
             </a:pPr>
             <a:r>
-              <a:t>This companion deck begins after Madhyasth Darshan has been stated on its own terms. Its task is comparative: Advaita Vedanta, contemporary metaphysical families, and empirical science are placed beside MD without treating them as one opposing camp. The aim is rigorous understanding rather than persuasion. The revised study now compares through common criteria and ends with three evidential bridge problems for MD itself.</a:t>
+              <a:t>This companion deck begins after Madhyasth Darshan has been stated on its own terms. Its task is comparative: Advaita Vedanta, contemporary metaphysical families, and empirical science are placed beside MD without treating them as one opposing camp. The aim is rigorous understanding rather than persuasion. Common criteria reveal both agreements and differences. Four questions remain for MD: identifying jeevan, explaining persistence, relating kinds of evidence, and grounding obligation.</a:t>
             </a:r>
           </a:p>
         </p:txBody>
@@ -677,7 +677,35 @@
               <a:buNone/>
             </a:pPr>
             <a:r>
-              <a:t>Causal language must remain precise. MD’s satta is mahakaran in the sustaining sense, not an efficient maker; units really transform. Advaita teaches effect–cause non-difference and later vivarta at vyavahara, while causal plurality is not final at paramartha. Physical explanation uses several formal and historical resources rather than one universal efficient-cause doctrine. Conservation cannot be converted into direct confirmation of either Advaita or MD.</a:t>
+              <a:t>Causal language must remain precise. MD’s satta is mahakaran in the sustaining sense, not an efficient maker; units really transform. Advaita teaches effect–cause non-difference and later vivarta at vyavahara, while causal plurality is not final at paramartha. Physical explanation uses several formal and historical resources rather than one universal efficient-cause doctrine. Conservation cannot be converted into direct confirmation of either Advaita or MD. Physicalism alone does not determine an ethical theory; moral realism, constructivism, contractualism and other approaches require additional premises.</a:t>
+            </a:r>
+          </a:p>
+          <a:p xmlns:a="http://schemas.openxmlformats.org/drawingml/2006/main">
+            <a:pPr marL="0" indent="0" algn="l">
+              <a:spcBef>
+                <a:spcPts val="0"/>
+              </a:spcBef>
+              <a:spcAft>
+                <a:spcPts val="0"/>
+              </a:spcAft>
+              <a:buNone/>
+            </a:pPr>
+            <a:r>
+              <a:t/>
+            </a:r>
+          </a:p>
+          <a:p xmlns:a="http://schemas.openxmlformats.org/drawingml/2006/main">
+            <a:pPr marL="0" indent="0" algn="l">
+              <a:spcBef>
+                <a:spcPts val="0"/>
+              </a:spcBef>
+              <a:spcAft>
+                <a:spcPts val="0"/>
+              </a:spcAft>
+              <a:buNone/>
+            </a:pPr>
+            <a:r>
+              <a:t>Sources: study §§3.5, 5.2–5.3.6.</a:t>
             </a:r>
           </a:p>
         </p:txBody>
@@ -756,7 +784,7 @@
               <a:buNone/>
             </a:pPr>
             <a:r>
-              <a:t>The methods are neither interchangeable nor beyond comparison. MD’s conduct-evidence is a substantial practical standard: understanding should become visible as resolution, justice, mutual fulfilment, and participation in orderliness. Advaita claims a distinct role for Upanishadic shabda supported by reasoning and contemplation. Philosophy tests coherence and explanatory adequacy. Science tests public operational consequences. The revision keeps these warrants distinct so that success at one level is not misreported as success at every level.</a:t>
+              <a:t>The methods are neither interchangeable nor beyond comparison. MD’s conduct-evidence is a substantial practical standard: understanding should become visible as resolution, justice, mutual fulfilment, and participation in orderliness. Advaita claims a distinct role for Upanishadic shabda supported by reasoning and contemplation. Philosophy tests coherence and explanatory adequacy. Science tests public operational consequences. Keeping these warrants distinct prevents success at one level from being misreported as success at every level.</a:t>
             </a:r>
           </a:p>
         </p:txBody>
@@ -835,7 +863,35 @@
               <a:buNone/>
             </a:pPr>
             <a:r>
-              <a:t>Shared vocabulary can obscure the central difference. Advaita’s Sat, Chit, and Ananda are not separable components but descriptions of one partless Brahman. MD distributes the relevant functions: beingness is coexistence, Omnipresence is the ground of intelligibility, and active knowing belongs to jeevan. Bliss is realised harmony in awakened living. The limited agreement concerns resistance to reducing the first person to an observed brain-state, not a common ontology of consciousness.</a:t>
+              <a:t>Shared vocabulary can obscure the central difference. Advaita’s Sat, Chit, and Ananda are not separable components but descriptions of one partless Brahman. MD distributes the relevant functions: beingness is coexistence, Omnipresence is the ground of intelligibility, and active knowing belongs to jeevan. In MD’s faculty sequence, bliss is harmony between buddhi and atma and belongs to buddhi; ultimate bliss is realisation at atma. Awakened understanding is evidenced in conduct. These distinctions prevent a direct identity between MD’s bliss and Advaita’s partless fullness. The limited agreement concerns resistance to reducing the first person to an observed brain-state.</a:t>
+            </a:r>
+          </a:p>
+          <a:p xmlns:a="http://schemas.openxmlformats.org/drawingml/2006/main">
+            <a:pPr marL="0" indent="0" algn="l">
+              <a:spcBef>
+                <a:spcPts val="0"/>
+              </a:spcBef>
+              <a:spcAft>
+                <a:spcPts val="0"/>
+              </a:spcAft>
+              <a:buNone/>
+            </a:pPr>
+            <a:r>
+              <a:t/>
+            </a:r>
+          </a:p>
+          <a:p xmlns:a="http://schemas.openxmlformats.org/drawingml/2006/main">
+            <a:pPr marL="0" indent="0" algn="l">
+              <a:spcBef>
+                <a:spcPts val="0"/>
+              </a:spcBef>
+              <a:spcAft>
+                <a:spcPts val="0"/>
+              </a:spcAft>
+              <a:buNone/>
+            </a:pPr>
+            <a:r>
+              <a:t>Sources: TU 2.1.1, 2.7; JV PDF p.138; MVD pp.100–101; study §§1.9, 1.14, 5.6.</a:t>
             </a:r>
           </a:p>
         </p:txBody>
@@ -914,7 +970,35 @@
               <a:buNone/>
             </a:pPr>
             <a:r>
-              <a:t>This slide removes the old one-to-one arrows. Brahman and satta can be compared as formless and non-transforming only if their different relation to plurality is kept explicit. Atman is not equivalent to MD’s atma: Advaita’s Self is Brahman, while MD’s atma is a faculty within a distinct jeevan. Jiva and deluded jeevan share a practical problem of ignorance, but liberation has opposite implications for individuality. Maya, adhyasa, mithya, governing Ishvara, and dissolution of separate self do not transfer into MD.</a:t>
+              <a:t>Brahman and satta can be compared as formless and non-transforming only if their different relation to plurality is kept explicit. Atman is not equivalent to MD’s atma: Advaita’s Self is Brahman, while MD’s atma is a faculty within a distinct jeevan. Jiva and deluded jeevan share a practical problem of ignorance, but liberation has different implications for individuality. Advaita sublates the belief in independently real individuality: ultimately the Self is Brahman, rather than a distinct individual knower. This is removal of ignorance, not the causal destruction of a previously independent self. MD’s awakening preserves permanently distinct jeevan. Maya, adhyasa, mithya and governing Ishvara therefore cannot be transferred into MD as equivalent categories.</a:t>
+            </a:r>
+          </a:p>
+          <a:p xmlns:a="http://schemas.openxmlformats.org/drawingml/2006/main">
+            <a:pPr marL="0" indent="0" algn="l">
+              <a:spcBef>
+                <a:spcPts val="0"/>
+              </a:spcBef>
+              <a:spcAft>
+                <a:spcPts val="0"/>
+              </a:spcAft>
+              <a:buNone/>
+            </a:pPr>
+            <a:r>
+              <a:t/>
+            </a:r>
+          </a:p>
+          <a:p xmlns:a="http://schemas.openxmlformats.org/drawingml/2006/main">
+            <a:pPr marL="0" indent="0" algn="l">
+              <a:spcBef>
+                <a:spcPts val="0"/>
+              </a:spcBef>
+              <a:spcAft>
+                <a:spcPts val="0"/>
+              </a:spcAft>
+              <a:buNone/>
+            </a:pPr>
+            <a:r>
+              <a:t>Sources: study §§2.9, 5.7.</a:t>
             </a:r>
           </a:p>
         </p:txBody>
@@ -993,7 +1077,7 @@
               <a:buNone/>
             </a:pPr>
             <a:r>
-              <a:t>The primary account locates sentience in constitutional completeness, but independent identification in contemporary physical terms remains open. Its atomic, imaging and five-force claims also require a justified choice between literal and analogical readings. Persistence raises both an empirical question and a conceptual one: what makes this jeevan the same individual, and how do sanskar and memory relate to that continuity? Saturation and physical conservation do not independently establish personal survival. Conduct-evidence must be distinguished from physical measurement; niyati-kram and evolutionary history need explicit comparison rather than an assumed agreement or contradiction.</a:t>
+              <a:t>Four questions organise the further work. First, the primary account locates sentience in constitutional completeness, but independent identification in contemporary physical terms remains open. Its atomic, imaging and five-force claims also require a justified choice between literal and analogical readings. Second, MD grounds persistence in a constitution that no longer gains or loses particles, rather than generic physical conservation. What individuates this jeevan, and how do sanskar, memory, joint bodily operation and reassociation bear on its continuity? Third, conduct-evidence must be distinguished from physical measurement; niyati-kram and evolutionary history need explicit comparison. Fourth, MD connects obligation to happiness as human dharma, essentiality as value, and definite expectations within relationships. These premises need justification: coexistence alone does not establish what a person ought to do.</a:t>
             </a:r>
           </a:p>
           <a:p xmlns:a="http://schemas.openxmlformats.org/drawingml/2006/main">
@@ -1021,7 +1105,7 @@
               <a:buNone/>
             </a:pPr>
             <a:r>
-              <a:t>Sources: MVD pp. 91, 115; SB pp. 55, 59, 84–85, 114, 251–252; JV PDF pp. 20, 55; study §6.2.</a:t>
+              <a:t>Sources: MVD pp.91, 115; SB pp.55, 59, 84–85, 114, 251–252; JV PDF pp.20, 55; study §§1.7.1, 1.9, 6.2.1–6.2.4.</a:t>
             </a:r>
           </a:p>
         </p:txBody>
@@ -1179,7 +1263,35 @@
               <a:buNone/>
             </a:pPr>
             <a:r>
-              <a:t>MD’s internal strength is integrative: coexistence, real units, beginninglessness, self, value, relationship, and humane conduct form one picture. The revision does not treat that internal coherence as proof against rivals. Constitutional completeness is textually specific, which is stronger than an undefined appeal to emergence, but it lacks a public identifier. Persistence is grounded in that completeness within MD, yet reassociation and joint operation remain unconfirmed. Niyati-kram and evolution should be compared through explicit levels and possible discriminating consequences.</a:t>
+              <a:t>MD’s internal strength is integrative: coexistence, real units, beginninglessness, self, value, relationship, and humane conduct form one picture. Internal coherence does not establish these claims against rivals. Constitutional completeness is a specific primary-text proposal, but it lacks a public identifier. Persistence is grounded in that completeness within MD, yet reassociation and joint operation remain unconfirmed. Niyati-kram and evolution should be compared through explicit levels and possible discriminating consequences. The normative account also needs justification for the premises connecting happiness, essentiality, relationship expectations and obligation; coexistence alone cannot supply that inference.</a:t>
+            </a:r>
+          </a:p>
+          <a:p xmlns:a="http://schemas.openxmlformats.org/drawingml/2006/main">
+            <a:pPr marL="0" indent="0" algn="l">
+              <a:spcBef>
+                <a:spcPts val="0"/>
+              </a:spcBef>
+              <a:spcAft>
+                <a:spcPts val="0"/>
+              </a:spcAft>
+              <a:buNone/>
+            </a:pPr>
+            <a:r>
+              <a:t/>
+            </a:r>
+          </a:p>
+          <a:p xmlns:a="http://schemas.openxmlformats.org/drawingml/2006/main">
+            <a:pPr marL="0" indent="0" algn="l">
+              <a:spcBef>
+                <a:spcPts val="0"/>
+              </a:spcBef>
+              <a:spcAft>
+                <a:spcPts val="0"/>
+              </a:spcAft>
+              <a:buNone/>
+            </a:pPr>
+            <a:r>
+              <a:t>Sources: study §§6.1–6.2.4.</a:t>
             </a:r>
           </a:p>
         </p:txBody>
@@ -1258,7 +1370,35 @@
               <a:buNone/>
             </a:pPr>
             <a:r>
-              <a:t>Close by returning to the distinctive two-term ontology rather than two refusals. MD keeps Omnipresence and real units co-eternal, locates change in units, preserves distinct jeevan, and gives final weight to relationships, values, and nature. Alignments are limited to particular questions: scientific realism on mind-independent nature, Advaita on resistance to reductive accounts of the knower, and several modern alternatives on the inadequacy of a simple substance picture. The unfinished work is the public evidential bridge named in Section 6.2.</a:t>
+              <a:t>MD keeps Omnipresence and real units co-eternal, locates change in units, preserves distinct jeevan, and gives final weight to relationships, values, and nature. Agreements concern particular questions: scientific realism also affirms mind-independent nature, while Advaita and several non-reductive philosophies resist reducing experience to a physical description. They disagree about the number, constitution and persistence of its bearers. Four questions remain: public identification of constitutional completeness; individuation, persistence and joint operation with a body; the relation between conduct-evidence, scientific measurement and evolutionary history; and the premises connecting coexistence to obligation.</a:t>
+            </a:r>
+          </a:p>
+          <a:p xmlns:a="http://schemas.openxmlformats.org/drawingml/2006/main">
+            <a:pPr marL="0" indent="0" algn="l">
+              <a:spcBef>
+                <a:spcPts val="0"/>
+              </a:spcBef>
+              <a:spcAft>
+                <a:spcPts val="0"/>
+              </a:spcAft>
+              <a:buNone/>
+            </a:pPr>
+            <a:r>
+              <a:t/>
+            </a:r>
+          </a:p>
+          <a:p xmlns:a="http://schemas.openxmlformats.org/drawingml/2006/main">
+            <a:pPr marL="0" indent="0" algn="l">
+              <a:spcBef>
+                <a:spcPts val="0"/>
+              </a:spcBef>
+              <a:spcAft>
+                <a:spcPts val="0"/>
+              </a:spcAft>
+              <a:buNone/>
+            </a:pPr>
+            <a:r>
+              <a:t>Sources: study §§6.2.1–6.2.4, 7.</a:t>
             </a:r>
           </a:p>
         </p:txBody>
@@ -1495,7 +1635,7 @@
               <a:buNone/>
             </a:pPr>
             <a:r>
-              <a:t>The revised causal account avoids assigning Samkhya’s real transformation doctrine to Advaita. The clay teaching establishes effect–cause non-difference: the effect has no being apart from its cause. Later Advaita uses vivarta for apparent name-form without alteration of Brahman. Maya and adhyasa explain dependence and mistaken identification; witness inquiry discloses the Self as Brahman. Ethics is not merely discarded after knowledge: disciplined action and loka-sangraha remain meaningful in embodied life, although agency is not ultimate.</a:t>
+              <a:t>Advaita’s causal account differs from Samkhya’s doctrine of real transformation. The clay teaching establishes effect–cause non-difference: the effect has no being apart from its cause. Later Advaita uses vivarta for apparent name-form without alteration of Brahman. Maya and adhyasa explain dependence and mistaken identification; witness inquiry discloses the Self as Brahman. Ethics is not merely discarded after knowledge: disciplined action and loka-sangraha remain meaningful in embodied life, although agency is not ultimate.</a:t>
             </a:r>
           </a:p>
         </p:txBody>
@@ -1574,7 +1714,35 @@
               <a:buNone/>
             </a:pPr>
             <a:r>
-              <a:t>Physicalism is not a single doctrine and it is not identical with empirical science. Identity theory, functionalism, non-reductive physicalism, emergentism, and illusionism make different commitments. Causal closure is a metaphysical interpretation of physical explanation and creates a real challenge for jeevan–body operation. The hard problem creates a counter-pressure but does not identify which non-reductive ontology is correct. The deck should keep both pressures in view.</a:t>
+              <a:t>Physicalism is not a single doctrine and is not identical with empirical science. Physicalist versions of functionalism require mental roles to be physically realised; functionalism by itself does not entail that premise. Weak emergence preserves dependence on lower-level physics, while strong emergence proposes irreducible causal powers. Illusionism challenges the phenomenal properties attributed to experience while retaining access and report. Eliminative materialism makes a different claim about folk-psychological categories such as belief and desire. Causal closure creates a serious challenge for jeevan–body operation. The hard problem creates a counter-pressure but does not select which non-reductive ontology is correct.</a:t>
+            </a:r>
+          </a:p>
+          <a:p xmlns:a="http://schemas.openxmlformats.org/drawingml/2006/main">
+            <a:pPr marL="0" indent="0" algn="l">
+              <a:spcBef>
+                <a:spcPts val="0"/>
+              </a:spcBef>
+              <a:spcAft>
+                <a:spcPts val="0"/>
+              </a:spcAft>
+              <a:buNone/>
+            </a:pPr>
+            <a:r>
+              <a:t/>
+            </a:r>
+          </a:p>
+          <a:p xmlns:a="http://schemas.openxmlformats.org/drawingml/2006/main">
+            <a:pPr marL="0" indent="0" algn="l">
+              <a:spcBef>
+                <a:spcPts val="0"/>
+              </a:spcBef>
+              <a:spcAft>
+                <a:spcPts val="0"/>
+              </a:spcAft>
+              <a:buNone/>
+            </a:pPr>
+            <a:r>
+              <a:t>Sources: study §§3.1–3.4, including Kim 2005, Frankish 2016 and Churchland 1986.</a:t>
             </a:r>
           </a:p>
         </p:txBody>
@@ -1653,7 +1821,7 @@
               <a:buNone/>
             </a:pPr>
             <a:r>
-              <a:t>Aquinas explains a living human as one substance whose rational soul is its form; MD describes joint living of a pranic body and a constitutionally complete jeevan. Aquinas allows the soul to subsist after death, while distinguishing it from a complete human person. Leibniz offers an analogy of plurality and persistence, but his monads are partless and windowless; jeevan has a nucleus and orbital constitution. Perception belongs to monads generally, whereas MD restricts sentience to jeevan. These are comparisons along specified axes, not steps toward one system.</a:t>
+              <a:t>Aquinas explains a living human as one substance whose rational soul is its form; MD describes joint living of a pranic body and a constitutionally complete jeevan. Aquinas allows the soul to subsist after death, while distinguishing it from a complete human person. Leibniz offers an analogy of plurality and persistence, but his monads are partless and windowless; jeevan has a nucleus and orbital constitution. Perception belongs to monads generally, whereas MD restricts sentience to jeevan. Panpsychism can overlap with physicalism, as in Strawson’s account; neutral monism instead derives mental and physical descriptions from common constituents. Neither is equivalent to MD’s actionless satta and distinct sentient units. These comparisons concern specified axes.</a:t>
             </a:r>
           </a:p>
           <a:p xmlns:a="http://schemas.openxmlformats.org/drawingml/2006/main">
@@ -1681,7 +1849,7 @@
               <a:buNone/>
             </a:pPr>
             <a:r>
-              <a:t>Sources: Aquinas, Summa Theologiae I q.75–76; Leibniz, Monadology §§1–3, 6–7, 14, 18–19, 78–81; study §§3.6.1–3.6.3.</a:t>
+              <a:t>Sources: Aquinas, Summa Theologiae I q.75–76; Leibniz, Monadology §§1–3, 6–7, 14, 18–19, 78–81; Strawson 2006; study §§3.3, 3.6.1–3.6.3, 3.6.5.</a:t>
             </a:r>
           </a:p>
         </p:txBody>
@@ -1760,7 +1928,35 @@
               <a:buNone/>
             </a:pPr>
             <a:r>
-              <a:t>The revised science section is deliberately restrained. Predictive processing and self-model theory explain aspects of embodied regulation and first-person organisation. Competing consciousness programmes propose testable mechanisms, but no consensus identifies a complete theory of consciousness. Brain-death criteria establish the irreversible end of measurable personal function; they do not, by themselves, prove a complete metaphysics of the bearer. MD therefore faces a demand for discriminating evidence, while science should not be made to assert more than its methods establish.</a:t>
+              <a:t>Predictive processing and self-model theory explain aspects of embodied regulation and first-person organisation. Competing consciousness programmes propose testable mechanisms, but no consensus identifies a complete theory of consciousness. The cited United States consensus guideline treats brain death as death of the person, assessed through permanent loss of brain function as a whole and specified clinical criteria. This does not independently settle whether a non-physical subject survives; accepted measurement has not established such continuity. MD therefore faces a demand for discriminating evidence, while science should not be made to assert more than its methods establish.</a:t>
+            </a:r>
+          </a:p>
+          <a:p xmlns:a="http://schemas.openxmlformats.org/drawingml/2006/main">
+            <a:pPr marL="0" indent="0" algn="l">
+              <a:spcBef>
+                <a:spcPts val="0"/>
+              </a:spcBef>
+              <a:spcAft>
+                <a:spcPts val="0"/>
+              </a:spcAft>
+              <a:buNone/>
+            </a:pPr>
+            <a:r>
+              <a:t/>
+            </a:r>
+          </a:p>
+          <a:p xmlns:a="http://schemas.openxmlformats.org/drawingml/2006/main">
+            <a:pPr marL="0" indent="0" algn="l">
+              <a:spcBef>
+                <a:spcPts val="0"/>
+              </a:spcBef>
+              <a:spcAft>
+                <a:spcPts val="0"/>
+              </a:spcAft>
+              <a:buNone/>
+            </a:pPr>
+            <a:r>
+              <a:t>Sources: AAN/AAP/CNS/SCCM 2023; study §§4.5–4.6.</a:t>
             </a:r>
           </a:p>
         </p:txBody>
@@ -1839,7 +2035,35 @@
               <a:buNone/>
             </a:pPr>
             <a:r>
-              <a:t>Cosmology and conservation discipline the discussion but do not confirm MD. A finite reconstructed cosmic history does not settle whether existence as a whole began. Conservation laws are structural features of specific physical theories, not direct evidence for perpetual MD units or personal survival. The former claim that niyati-kram directly contradicts evolution has been removed. MD names an ordered relation among natural orders; evolutionary biology explains branching histories within living populations. The missing work is a precise mapping and a possible discriminating test.</a:t>
+              <a:t>Cosmology and conservation discipline the discussion but do not confirm MD. A finite reconstructed cosmic history does not settle whether existence as a whole began. In QFT, particle–antiparticle annihilation and pair creation change field states; particle number need not be conserved. Conservation concerns the quantities and conditions specified by a physical theory, not perpetual MD units or personal survival. MD’s niyati-kram names an ordered relation among natural orders; evolutionary biology explains branching histories within living populations. A precise mapping and possible discriminating tests are still needed.</a:t>
+            </a:r>
+          </a:p>
+          <a:p xmlns:a="http://schemas.openxmlformats.org/drawingml/2006/main">
+            <a:pPr marL="0" indent="0" algn="l">
+              <a:spcBef>
+                <a:spcPts val="0"/>
+              </a:spcBef>
+              <a:spcAft>
+                <a:spcPts val="0"/>
+              </a:spcAft>
+              <a:buNone/>
+            </a:pPr>
+            <a:r>
+              <a:t/>
+            </a:r>
+          </a:p>
+          <a:p xmlns:a="http://schemas.openxmlformats.org/drawingml/2006/main">
+            <a:pPr marL="0" indent="0" algn="l">
+              <a:spcBef>
+                <a:spcPts val="0"/>
+              </a:spcBef>
+              <a:spcAft>
+                <a:spcPts val="0"/>
+              </a:spcAft>
+              <a:buNone/>
+            </a:pPr>
+            <a:r>
+              <a:t>Sources: study §§4.2–4.4, 6.2.3.</a:t>
             </a:r>
           </a:p>
         </p:txBody>
@@ -1918,7 +2142,7 @@
               <a:buNone/>
             </a:pPr>
             <a:r>
-              <a:t>This slide replaces the former alliance triangle. The ten criteria are: ontological primitives; one–many structure and individuation; dependence between ground and particulars; world status and persistence; causation and transformation; consciousness, selfhood, and survival; time and cosmic history; method and evidence; value, ethics, and telos; and exposure to empirical or experiential correction. Pairwise agreements remain useful only when the specific criterion is named.</a:t>
+              <a:t>The ten criteria are: ontological primitives; one–many structure and individuation; dependence between ground and particulars; world status and persistence; causation and transformation; consciousness, selfhood, and survival; time and cosmic history; method and evidence; value, ethics, and telos; and exposure to empirical or experiential correction. Pairwise agreements remain useful only when the specific criterion is named.</a:t>
             </a:r>
           </a:p>
         </p:txBody>
@@ -1988,7 +2212,7 @@
   </p:cSld>
   <p:clrMap bg1="lt1" tx1="dk1" bg2="dk2" tx2="lt2" accent1="accent1" accent2="accent2" accent3="accent3" accent4="accent4" accent5="accent5" accent6="accent6" hlink="hlink" folHlink="folHlink"/>
   <p:sldLayoutIdLst>
-    <p:sldLayoutId xmlns:r="http://schemas.openxmlformats.org/officeDocument/2006/relationships" id="2147483649" r:id="R3140d1553a5344dc"/>
+    <p:sldLayoutId xmlns:r="http://schemas.openxmlformats.org/officeDocument/2006/relationships" id="2147483649" r:id="R4af9946c4e204450"/>
   </p:sldLayoutIdLst>
   <p:hf sldNum="0" hdr="0" ftr="0" dt="0"/>
   <p:txStyles>
@@ -5265,7 +5489,7 @@
                           <a:ea typeface="Calibri"/>
                           <a:cs typeface="Calibri"/>
                         </a:rPr>
-                        <a:t>Mind-independent physical or embodied organisation</a:t>
+                        <a:t>Physical organisation, embodied form, or mind-dependent ideas</a:t>
                       </a:r>
                     </a:p>
                   </a:txBody>
@@ -5515,7 +5739,7 @@
                           <a:ea typeface="Calibri"/>
                           <a:cs typeface="Calibri"/>
                         </a:rPr>
-                        <a:t>Generally no; some soul-form or monadic views allow persistence</a:t>
+                        <a:t>Physicalists usually deny survival; some soul or monad views allow it</a:t>
                       </a:r>
                     </a:p>
                   </a:txBody>
@@ -6659,7 +6883,7 @@
                           <a:ea typeface="Calibri"/>
                           <a:cs typeface="Calibri"/>
                         </a:rPr>
-                        <a:t>Realism, idealism, structuralism, and instrumentalism vary</a:t>
+                        <a:t>Scientific realism, idealism, structural realism, instrumentalism</a:t>
                       </a:r>
                     </a:p>
                   </a:txBody>
@@ -7909,7 +8133,7 @@
                           <a:ea typeface="Calibri"/>
                           <a:cs typeface="Calibri"/>
                         </a:rPr>
-                        <a:t>Ontology alone does not fix ethics; naturalisms and realisms compete</a:t>
+                        <a:t>Physicalism alone fixes no ethics; realist and constructivist ethics differ</a:t>
                       </a:r>
                     </a:p>
                   </a:txBody>
@@ -10509,7 +10733,7 @@
                           <a:ea typeface="Calibri"/>
                           <a:cs typeface="Calibri"/>
                         </a:rPr>
-                        <a:t>Realised harmony in awakened jeevan, evidenced in conduct</a:t>
+                        <a:t>Bliss: buddhi–atma harmony. Ultimate bliss: realisation at atma.</a:t>
                       </a:r>
                     </a:p>
                   </a:txBody>
@@ -10717,7 +10941,29 @@
                 <a:ea typeface="Calibri"/>
                 <a:cs typeface="Calibri"/>
               </a:rPr>
-              <a:t>CU 6.2.1  ·  TU 2.1.1  ·  DDV vv. 1–5  ·  VC v. 217  ·  </a:t>
+              <a:t>CU 6.2.1  ·  </a:t>
+            </a:r>
+            <a:r>
+              <a:rPr sz="950" b="0" i="1" u="none" cap="none">
+                <a:solidFill>
+                  <a:srgbClr val="5A6377"/>
+                </a:solidFill>
+                <a:latin typeface="Calibri"/>
+                <a:ea typeface="Calibri"/>
+                <a:cs typeface="Calibri"/>
+              </a:rPr>
+              <a:t>TU 2.1.1, 2.7</a:t>
+            </a:r>
+            <a:r>
+              <a:rPr sz="950" b="0" i="1" u="none" cap="none">
+                <a:solidFill>
+                  <a:srgbClr val="5A6377"/>
+                </a:solidFill>
+                <a:latin typeface="Calibri"/>
+                <a:ea typeface="Calibri"/>
+                <a:cs typeface="Calibri"/>
+              </a:rPr>
+              <a:t>  ·  DDV vv. 1–5  ·  VC v. 217  ·  </a:t>
             </a:r>
             <a:r>
               <a:rPr sz="950" b="0" i="1" u="none" cap="none">
@@ -11597,7 +11843,7 @@
                 <a:ea typeface="Calibri"/>
                 <a:cs typeface="Calibri"/>
               </a:rPr>
-              <a:t>Moksha / kaivalya — MD awakening preserves distinct jeevan</a:t>
+              <a:t>Moksha — MD awakening preserves distinct jeevan</a:t>
             </a:r>
           </a:p>
         </p:txBody>
@@ -11904,18 +12150,7 @@
                 <a:ea typeface="Calibri"/>
                 <a:cs typeface="Calibri"/>
               </a:rPr>
-              <a:t>§6.2  ·  </a:t>
-            </a:r>
-            <a:r>
-              <a:rPr sz="1050" b="1" i="0" u="none" cap="none">
-                <a:solidFill>
-                  <a:srgbClr val="9A6414"/>
-                </a:solidFill>
-                <a:latin typeface="Calibri"/>
-                <a:ea typeface="Calibri"/>
-                <a:cs typeface="Calibri"/>
-              </a:rPr>
-              <a:t>THREE EVIDENTIAL QUESTIONS</a:t>
+              <a:t>§6.2  ·  FOUR OPEN QUESTIONS</a:t>
             </a:r>
           </a:p>
         </p:txBody>
@@ -11976,7 +12211,7 @@
                 <a:ea typeface="Cambria"/>
                 <a:cs typeface="Cambria"/>
               </a:rPr>
-              <a:t>The open task is an evidential bridge</a:t>
+              <a:t>Four questions remain open</a:t>
             </a:r>
           </a:p>
         </p:txBody>
@@ -12037,7 +12272,7 @@
                 <a:ea typeface="Calibri"/>
                 <a:cs typeface="Calibri"/>
               </a:rPr>
-              <a:t>Public identification, personal continuity and the interpretation of physical claims remain open. These questions concern both evidence and explanatory adequacy.</a:t>
+              <a:t>Identifying jeevan, explaining persistence, comparing evidence and grounding obligation remain open.</a:t>
             </a:r>
           </a:p>
         </p:txBody>
@@ -12693,7 +12928,7 @@
                 <a:ea typeface="Calibri"/>
                 <a:cs typeface="Calibri"/>
               </a:rPr>
-              <a:t>MD’s own case rests on constitutional completeness—not generic conservation. The unanswered question is independent identification and testing.</a:t>
+              <a:t>6.2.4  ·  Value: justify happiness, relationship duties and fulfilment. Coexistence alone does not establish what a person ought to do.</a:t>
             </a:r>
           </a:p>
         </p:txBody>
@@ -14477,7 +14712,7 @@
                 <a:ea typeface="Calibri"/>
                 <a:cs typeface="Calibri"/>
               </a:rPr>
-              <a:t>§§6.1–6.2  ·  MD’S STRENGTH AND OPEN BRIDGE</a:t>
+              <a:t>§§6.1–6.2  ·  MD’S STRENGTH AND OPEN QUESTIONS</a:t>
             </a:r>
           </a:p>
         </p:txBody>
@@ -14538,7 +14773,7 @@
                 <a:ea typeface="Cambria"/>
                 <a:cs typeface="Cambria"/>
               </a:rPr>
-              <a:t>Coherence does not remove evidence duties</a:t>
+              <a:t>Coherence leaves questions open</a:t>
             </a:r>
           </a:p>
         </p:txBody>
@@ -14968,7 +15203,7 @@
                           <a:ea typeface="Calibri"/>
                           <a:cs typeface="Calibri"/>
                         </a:rPr>
-                        <a:t>Complexity and stronger claims require independent warrant</a:t>
+                        <a:t>Happiness, value and relational duties need independent justification</a:t>
                       </a:r>
                     </a:p>
                   </a:txBody>
@@ -15030,7 +15265,7 @@
                           <a:ea typeface="Calibri"/>
                           <a:cs typeface="Calibri"/>
                         </a:rPr>
-                        <a:t>State discriminating consequences</a:t>
+                        <a:t>Explain and test the premises of humane obligation</a:t>
                       </a:r>
                     </a:p>
                   </a:txBody>
@@ -15993,7 +16228,7 @@
                 <a:ea typeface="Cambria"/>
                 <a:cs typeface="Cambria"/>
               </a:rPr>
-              <a:t>Limited alignments, one open bridge</a:t>
+              <a:t>Agreements and open questions</a:t>
             </a:r>
           </a:p>
         </p:txBody>
@@ -16273,7 +16508,7 @@
                 <a:ea typeface="Calibri"/>
                 <a:cs typeface="Calibri"/>
               </a:rPr>
-              <a:t>With scientific realism on mind-independent nature; with Advaita against reductive accounts of the knower; with modern alternatives against a simple substance inventory.</a:t>
+              <a:t>With scientific realism on mind-independent nature; with Advaita and some modern alternatives on irreducible experience. Each agreement leaves major ontological differences.</a:t>
             </a:r>
           </a:p>
         </p:txBody>
@@ -16395,7 +16630,7 @@
                 <a:ea typeface="Calibri"/>
                 <a:cs typeface="Calibri"/>
               </a:rPr>
-              <a:t>What remains open: public identification of constitutional completeness; independent evidence for jeevan’s persistence and joint operation; and a clearer separation of evidence levels with an evolutionary mapping. Science constrains the bridge—it is not physicalism, and no stable alliance follows.</a:t>
+              <a:t>Open questions: identify constitutional completeness; test persistence and joint operation; relate evidence to evolutionary history; justify value and relational duties.</a:t>
             </a:r>
           </a:p>
         </p:txBody>
@@ -20682,7 +20917,7 @@
                 <a:ea typeface="Calibri"/>
                 <a:cs typeface="Calibri"/>
               </a:rPr>
-              <a:t>Mental states are individuated by role or higher-level organisation while remaining physically dependent.</a:t>
+              <a:t>Physicalist versions ground mental roles and higher-level organisation in physical realisations.</a:t>
             </a:r>
           </a:p>
         </p:txBody>
@@ -20802,7 +21037,7 @@
                 <a:ea typeface="Cambria"/>
                 <a:cs typeface="Cambria"/>
               </a:rPr>
-              <a:t>Emergent and eliminative replies</a:t>
+              <a:t>Emergence and illusionism</a:t>
             </a:r>
           </a:p>
         </p:txBody>
@@ -20863,7 +21098,7 @@
                 <a:ea typeface="Calibri"/>
                 <a:cs typeface="Calibri"/>
               </a:rPr>
-              <a:t>Emergence posits novel organisation or powers; illusionism redescribes phenomenal reports rather than adding a separate bearer.</a:t>
+              <a:t>Weak emergence preserves physical dependence. Illusionism explains why experience seems to have phenomenal properties.</a:t>
             </a:r>
           </a:p>
         </p:txBody>
@@ -22288,7 +22523,7 @@
                           <a:ea typeface="Calibri"/>
                           <a:cs typeface="Calibri"/>
                         </a:rPr>
-                        <a:t>Rejects a simple matter-only intrinsic nature</a:t>
+                        <a:t>Experience or neutral constituents at the base</a:t>
                       </a:r>
                     </a:p>
                   </a:txBody>
@@ -22350,7 +22585,7 @@
                           <a:ea typeface="Calibri"/>
                           <a:cs typeface="Calibri"/>
                         </a:rPr>
-                        <a:t>Experience or neutral reality is distributed or constitutive, not MD’s threshold</a:t>
+                        <a:t>Constitution or combination differs from MD’s sentient-atom threshold</a:t>
                       </a:r>
                     </a:p>
                   </a:txBody>
@@ -23356,7 +23591,7 @@
                 <a:ea typeface="Calibri"/>
                 <a:cs typeface="Calibri"/>
               </a:rPr>
-              <a:t>Accepted criteria mark irreversible loss of measurable organismal and personal function. No public post-death continuity has been established.</a:t>
+              <a:t>Clinical brain-death criteria concern permanent loss of brain function as a whole. Post-death subject continuity remains unestablished.</a:t>
             </a:r>
           </a:p>
         </p:txBody>
@@ -24267,7 +24502,7 @@
                 <a:ea typeface="Calibri"/>
                 <a:cs typeface="Calibri"/>
               </a:rPr>
-              <a:t>QFT tracks fields, excitations, symmetries, and conserved quantities. Transformation without everyday annihilation is a parallel, but fields are not bounded ikai and satta is not a dynamical field.</a:t>
+              <a:t>QFT permits changing particle numbers while preserving appropriate conserved quantities. This neither proves perpetual ikai nor identifies satta with a physical field.</a:t>
             </a:r>
           </a:p>
         </p:txBody>

</xml_diff>